<commit_message>
fix(templates): remove side logo from blue portability theme
</commit_message>
<xml_diff>
--- a/tests/quality/fixtures/portability/templates/portability-side-logo.pptx
+++ b/tests/quality/fixtures/portability/templates/portability-side-logo.pptx
@@ -966,30 +966,6 @@
           </a:p>
         </p:txBody>
       </p:sp>
-      <p:pic>
-        <p:nvPicPr>
-          <p:cNvPr id="20" name="Logo" descr="Company logo"/>
-          <p:cNvPicPr>
-            <a:picLocks noChangeAspect="1"/>
-          </p:cNvPicPr>
-          <p:nvPr userDrawn="1"/>
-        </p:nvPicPr>
-        <p:blipFill>
-          <a:blip r:embed="rId20"/>
-          <a:stretch>
-            <a:fillRect/>
-          </a:stretch>
-        </p:blipFill>
-        <p:spPr>
-          <a:xfrm>
-            <a:off x="11430000" y="4572000"/>
-            <a:ext cx="640080" cy="1600200"/>
-          </a:xfrm>
-          <a:prstGeom prst="rect">
-            <a:avLst/>
-          </a:prstGeom>
-        </p:spPr>
-      </p:pic>
     </p:spTree>
   </p:cSld>
   <p:clrMap bg1="lt1" tx1="dk1" bg2="lt2" tx2="dk2" accent1="accent1" accent2="accent2" accent3="accent3" accent4="accent4" accent5="accent5" accent6="accent6" hlink="hlink" folHlink="folHlink"/>

</xml_diff>